<commit_message>
chore: regenerate the exercise decks from the HTML guides
The decks were generated before Exercise 6b (AI Dev SDK) and Exercise 9b (AI
Commerce) existed, so they were missing both: fundamental 175 -> 197 slides,
professional 247 -> 263. They also now show the typed constants the exercise
repos use.

Two snippets in the highlighted HTML still carried an untyped constant
(06-configuration, 07-storage-client) - pandoc splits the tokens into spans, so
the plain-text pass over the guides missed them.

Eight HTML guides had no <title> beyond their filename, which is what the deck
uses for the section divider ("07-storage-client" instead of "Exercise 14:
Storage Client"). Titles now come from each guide's own H1.

Co-Authored-By: Claude Opus 5 (1M context) <noreply@anthropic.com>
</commit_message>
<xml_diff>
--- a/guides-pptx/spryker-academy-ai.pptx
+++ b/guides-pptx/spryker-academy-ai.pptx
@@ -15233,7 +15233,7 @@
               </a:defRPr>
             </a:pPr>
             <a:r>
-              <a:t>01-back-office-assistant-setup</a:t>
+              <a:t>Setup: Install the Back Office Assistant</a:t>
             </a:r>
           </a:p>
         </p:txBody>
@@ -15575,7 +15575,7 @@
               </a:defRPr>
             </a:pPr>
             <a:r>
-              <a:t>02-ai-foundation-hello</a:t>
+              <a:t>Exercise 19: Hello AI - A Storefront API Backed by an LLM</a:t>
             </a:r>
           </a:p>
         </p:txBody>
@@ -20657,7 +20657,7 @@
               </a:defRPr>
             </a:pPr>
             <a:r>
-              <a:t>03-ai-foundation-catalog</a:t>
+              <a:t>Exercise 20: Ask the Catalog - Tool Calling and Structured Answers</a:t>
             </a:r>
           </a:p>
         </p:txBody>
@@ -28574,7 +28574,7 @@
               </a:defRPr>
             </a:pPr>
             <a:r>
-              <a:t>04-ai-foundation-agent</a:t>
+              <a:t>Exercise 21: AI Foundation - Product Creation Agent</a:t>
             </a:r>
           </a:p>
         </p:txBody>

</xml_diff>

<commit_message>
feat: Exercise 12 covers the Backend API, pagination and the supplier-locations include
- Guide 05: Storefront vs Backend API, page[offset]/page[limit], ?include=supplier-locations,
  Backend provider through the Supplier facade, new troubleshooting rows
- load.sh: fix the demo shop's Backend API route import (it looked for src/Generated/Api/Backend
  in config/, so the Backend API had no API Platform routes)
- Intermediate presentation: slides for Storefront vs Backend, pagination and includes
- Regenerated HTML guides and PPTX decks

Co-Authored-By: Claude Opus 5.5 <noreply@anthropic.com>
</commit_message>
<xml_diff>
--- a/guides-pptx/spryker-academy-ai.pptx
+++ b/guides-pptx/spryker-academy-ai.pptx
@@ -16051,7 +16051,7 @@
               </a:defRPr>
             </a:pPr>
             <a:r>
-              <a:t>• Completed Exercise 12 (Glue Storefront API). You know resource schemas, providers, and glue api:generate .</a:t>
+              <a:t>• Completed Exercise 12 (Glue Storefront and Backend API). You know resource schemas, providers, and glue api:generate .</a:t>
             </a:r>
           </a:p>
         </p:txBody>
@@ -19298,205 +19298,7 @@
               </a:defRPr>
             </a:pPr>
             <a:r>
-              <a:t>❝ Why glue cache:clear ? The Glue application compiles a Symfony container that caches the API Platform source directories and routes, and cache:empty-all does not touch it. In the demo shop glue.eu.spryker.local is served by the GLUE application, so that is the one to generate and clear ( GLUE_STOREFRONT is not the application behind that host). If the endpoint still answers 404 or 500, see Troubleshooting in the Glue Storefront API guide .</a:t>
-            </a:r>
-          </a:p>
-          <a:p>
-            <a:pPr>
-              <a:spcAft>
-                <a:spcPts val="800"/>
-              </a:spcAft>
-              <a:defRPr sz="1600">
-                <a:solidFill>
-                  <a:srgbClr val="1A1A1A"/>
-                </a:solidFill>
-              </a:defRPr>
-            </a:pPr>
-            <a:r>
-              <a:t>Send the first message:</a:t>
-            </a:r>
-          </a:p>
-          <a:p>
-            <a:pPr>
-              <a:spcBef>
-                <a:spcPts val="0"/>
-              </a:spcBef>
-              <a:spcAft>
-                <a:spcPts val="0"/>
-              </a:spcAft>
-            </a:pPr>
-            <a:r>
-              <a:rPr sz="900">
-                <a:solidFill>
-                  <a:srgbClr val="2D2D2D"/>
-                </a:solidFill>
-                <a:latin typeface="Consolas"/>
-              </a:rPr>
-              <a:t>curl</a:t>
-            </a:r>
-            <a:r>
-              <a:rPr sz="900">
-                <a:solidFill>
-                  <a:srgbClr val="2D2D2D"/>
-                </a:solidFill>
-                <a:latin typeface="Consolas"/>
-              </a:rPr>
-              <a:t> </a:t>
-            </a:r>
-            <a:r>
-              <a:rPr sz="900">
-                <a:solidFill>
-                  <a:srgbClr val="2D2D2D"/>
-                </a:solidFill>
-                <a:latin typeface="Consolas"/>
-              </a:rPr>
-              <a:t>-s</a:t>
-            </a:r>
-            <a:r>
-              <a:rPr sz="900">
-                <a:solidFill>
-                  <a:srgbClr val="2D2D2D"/>
-                </a:solidFill>
-                <a:latin typeface="Consolas"/>
-              </a:rPr>
-              <a:t> </a:t>
-            </a:r>
-            <a:r>
-              <a:rPr sz="900">
-                <a:solidFill>
-                  <a:srgbClr val="2D2D2D"/>
-                </a:solidFill>
-                <a:latin typeface="Consolas"/>
-              </a:rPr>
-              <a:t>-X</a:t>
-            </a:r>
-            <a:r>
-              <a:rPr sz="900">
-                <a:solidFill>
-                  <a:srgbClr val="2D2D2D"/>
-                </a:solidFill>
-                <a:latin typeface="Consolas"/>
-              </a:rPr>
-              <a:t> POST http://glue.eu.spryker.local/ai-chats </a:t>
-            </a:r>
-            <a:r>
-              <a:rPr sz="900">
-                <a:solidFill>
-                  <a:srgbClr val="902000"/>
-                </a:solidFill>
-                <a:latin typeface="Consolas"/>
-              </a:rPr>
-              <a:t>\</a:t>
-            </a:r>
-          </a:p>
-          <a:p>
-            <a:pPr>
-              <a:spcBef>
-                <a:spcPts val="0"/>
-              </a:spcBef>
-              <a:spcAft>
-                <a:spcPts val="0"/>
-              </a:spcAft>
-            </a:pPr>
-            <a:r>
-              <a:rPr sz="900">
-                <a:solidFill>
-                  <a:srgbClr val="2D2D2D"/>
-                </a:solidFill>
-                <a:latin typeface="Consolas"/>
-              </a:rPr>
-              <a:t>  </a:t>
-            </a:r>
-            <a:r>
-              <a:rPr sz="900">
-                <a:solidFill>
-                  <a:srgbClr val="2D2D2D"/>
-                </a:solidFill>
-                <a:latin typeface="Consolas"/>
-              </a:rPr>
-              <a:t>-H</a:t>
-            </a:r>
-            <a:r>
-              <a:rPr sz="900">
-                <a:solidFill>
-                  <a:srgbClr val="2D2D2D"/>
-                </a:solidFill>
-                <a:latin typeface="Consolas"/>
-              </a:rPr>
-              <a:t> </a:t>
-            </a:r>
-            <a:r>
-              <a:rPr sz="900">
-                <a:solidFill>
-                  <a:srgbClr val="4070A0"/>
-                </a:solidFill>
-                <a:latin typeface="Consolas"/>
-              </a:rPr>
-              <a:t>'Content-Type: application/vnd.api+json'</a:t>
-            </a:r>
-            <a:r>
-              <a:rPr sz="900">
-                <a:solidFill>
-                  <a:srgbClr val="2D2D2D"/>
-                </a:solidFill>
-                <a:latin typeface="Consolas"/>
-              </a:rPr>
-              <a:t> </a:t>
-            </a:r>
-            <a:r>
-              <a:rPr sz="900">
-                <a:solidFill>
-                  <a:srgbClr val="902000"/>
-                </a:solidFill>
-                <a:latin typeface="Consolas"/>
-              </a:rPr>
-              <a:t>\</a:t>
-            </a:r>
-          </a:p>
-          <a:p>
-            <a:pPr>
-              <a:spcBef>
-                <a:spcPts val="0"/>
-              </a:spcBef>
-              <a:spcAft>
-                <a:spcPts val="0"/>
-              </a:spcAft>
-            </a:pPr>
-            <a:r>
-              <a:rPr sz="900">
-                <a:solidFill>
-                  <a:srgbClr val="2D2D2D"/>
-                </a:solidFill>
-                <a:latin typeface="Consolas"/>
-              </a:rPr>
-              <a:t>  </a:t>
-            </a:r>
-            <a:r>
-              <a:rPr sz="900">
-                <a:solidFill>
-                  <a:srgbClr val="2D2D2D"/>
-                </a:solidFill>
-                <a:latin typeface="Consolas"/>
-              </a:rPr>
-              <a:t>-d</a:t>
-            </a:r>
-            <a:r>
-              <a:rPr sz="900">
-                <a:solidFill>
-                  <a:srgbClr val="2D2D2D"/>
-                </a:solidFill>
-                <a:latin typeface="Consolas"/>
-              </a:rPr>
-              <a:t> </a:t>
-            </a:r>
-            <a:r>
-              <a:rPr sz="900">
-                <a:solidFill>
-                  <a:srgbClr val="4070A0"/>
-                </a:solidFill>
-                <a:latin typeface="Consolas"/>
-              </a:rPr>
-              <a:t>'{"data":{"type":"ai-chats","attributes":{"message":"Hello world! My name is Hidran."}}}'</a:t>
+              <a:t>❝ Why glue cache:clear ? The Glue application compiles a Symfony container that caches the API Platform source directories and routes, and cache:empty-all does not touch it. In the demo shop glue.eu.spryker.local is served by the GLUE application, so that is the one to generate and clear ( GLUE_STOREFRONT is not the application behind that host). api:generate only writes the resource classes; the cache is what Glue serves from, so it has to be rebuilt after every generate. The full explanation is Why cache:clear Follows api:generate in the Glue Storefront API guide ; if the endpoint still answers 404 or 500, see Troubleshooting there.</a:t>
             </a:r>
           </a:p>
         </p:txBody>
@@ -19618,6 +19420,204 @@
             <a:spAutoFit/>
           </a:bodyPr>
           <a:lstStyle/>
+          <a:p>
+            <a:pPr>
+              <a:spcAft>
+                <a:spcPts val="800"/>
+              </a:spcAft>
+              <a:defRPr sz="1600">
+                <a:solidFill>
+                  <a:srgbClr val="1A1A1A"/>
+                </a:solidFill>
+              </a:defRPr>
+            </a:pPr>
+            <a:r>
+              <a:t>Send the first message:</a:t>
+            </a:r>
+          </a:p>
+          <a:p>
+            <a:pPr>
+              <a:spcBef>
+                <a:spcPts val="0"/>
+              </a:spcBef>
+              <a:spcAft>
+                <a:spcPts val="0"/>
+              </a:spcAft>
+            </a:pPr>
+            <a:r>
+              <a:rPr sz="900">
+                <a:solidFill>
+                  <a:srgbClr val="2D2D2D"/>
+                </a:solidFill>
+                <a:latin typeface="Consolas"/>
+              </a:rPr>
+              <a:t>curl</a:t>
+            </a:r>
+            <a:r>
+              <a:rPr sz="900">
+                <a:solidFill>
+                  <a:srgbClr val="2D2D2D"/>
+                </a:solidFill>
+                <a:latin typeface="Consolas"/>
+              </a:rPr>
+              <a:t> </a:t>
+            </a:r>
+            <a:r>
+              <a:rPr sz="900">
+                <a:solidFill>
+                  <a:srgbClr val="2D2D2D"/>
+                </a:solidFill>
+                <a:latin typeface="Consolas"/>
+              </a:rPr>
+              <a:t>-s</a:t>
+            </a:r>
+            <a:r>
+              <a:rPr sz="900">
+                <a:solidFill>
+                  <a:srgbClr val="2D2D2D"/>
+                </a:solidFill>
+                <a:latin typeface="Consolas"/>
+              </a:rPr>
+              <a:t> </a:t>
+            </a:r>
+            <a:r>
+              <a:rPr sz="900">
+                <a:solidFill>
+                  <a:srgbClr val="2D2D2D"/>
+                </a:solidFill>
+                <a:latin typeface="Consolas"/>
+              </a:rPr>
+              <a:t>-X</a:t>
+            </a:r>
+            <a:r>
+              <a:rPr sz="900">
+                <a:solidFill>
+                  <a:srgbClr val="2D2D2D"/>
+                </a:solidFill>
+                <a:latin typeface="Consolas"/>
+              </a:rPr>
+              <a:t> POST http://glue.eu.spryker.local/ai-chats </a:t>
+            </a:r>
+            <a:r>
+              <a:rPr sz="900">
+                <a:solidFill>
+                  <a:srgbClr val="902000"/>
+                </a:solidFill>
+                <a:latin typeface="Consolas"/>
+              </a:rPr>
+              <a:t>\</a:t>
+            </a:r>
+          </a:p>
+          <a:p>
+            <a:pPr>
+              <a:spcBef>
+                <a:spcPts val="0"/>
+              </a:spcBef>
+              <a:spcAft>
+                <a:spcPts val="0"/>
+              </a:spcAft>
+            </a:pPr>
+            <a:r>
+              <a:rPr sz="900">
+                <a:solidFill>
+                  <a:srgbClr val="2D2D2D"/>
+                </a:solidFill>
+                <a:latin typeface="Consolas"/>
+              </a:rPr>
+              <a:t>  </a:t>
+            </a:r>
+            <a:r>
+              <a:rPr sz="900">
+                <a:solidFill>
+                  <a:srgbClr val="2D2D2D"/>
+                </a:solidFill>
+                <a:latin typeface="Consolas"/>
+              </a:rPr>
+              <a:t>-H</a:t>
+            </a:r>
+            <a:r>
+              <a:rPr sz="900">
+                <a:solidFill>
+                  <a:srgbClr val="2D2D2D"/>
+                </a:solidFill>
+                <a:latin typeface="Consolas"/>
+              </a:rPr>
+              <a:t> </a:t>
+            </a:r>
+            <a:r>
+              <a:rPr sz="900">
+                <a:solidFill>
+                  <a:srgbClr val="4070A0"/>
+                </a:solidFill>
+                <a:latin typeface="Consolas"/>
+              </a:rPr>
+              <a:t>'Content-Type: application/vnd.api+json'</a:t>
+            </a:r>
+            <a:r>
+              <a:rPr sz="900">
+                <a:solidFill>
+                  <a:srgbClr val="2D2D2D"/>
+                </a:solidFill>
+                <a:latin typeface="Consolas"/>
+              </a:rPr>
+              <a:t> </a:t>
+            </a:r>
+            <a:r>
+              <a:rPr sz="900">
+                <a:solidFill>
+                  <a:srgbClr val="902000"/>
+                </a:solidFill>
+                <a:latin typeface="Consolas"/>
+              </a:rPr>
+              <a:t>\</a:t>
+            </a:r>
+          </a:p>
+          <a:p>
+            <a:pPr>
+              <a:spcBef>
+                <a:spcPts val="0"/>
+              </a:spcBef>
+              <a:spcAft>
+                <a:spcPts val="0"/>
+              </a:spcAft>
+            </a:pPr>
+            <a:r>
+              <a:rPr sz="900">
+                <a:solidFill>
+                  <a:srgbClr val="2D2D2D"/>
+                </a:solidFill>
+                <a:latin typeface="Consolas"/>
+              </a:rPr>
+              <a:t>  </a:t>
+            </a:r>
+            <a:r>
+              <a:rPr sz="900">
+                <a:solidFill>
+                  <a:srgbClr val="2D2D2D"/>
+                </a:solidFill>
+                <a:latin typeface="Consolas"/>
+              </a:rPr>
+              <a:t>-d</a:t>
+            </a:r>
+            <a:r>
+              <a:rPr sz="900">
+                <a:solidFill>
+                  <a:srgbClr val="2D2D2D"/>
+                </a:solidFill>
+                <a:latin typeface="Consolas"/>
+              </a:rPr>
+              <a:t> </a:t>
+            </a:r>
+            <a:r>
+              <a:rPr sz="900">
+                <a:solidFill>
+                  <a:srgbClr val="4070A0"/>
+                </a:solidFill>
+                <a:latin typeface="Consolas"/>
+              </a:rPr>
+              <a:t>'{"data":{"type":"ai-chats","attributes":{"message":"Hello world! My name is Hidran."}}}'</a:t>
+            </a:r>
+          </a:p>
           <a:p>
             <a:pPr>
               <a:spcBef>

</xml_diff>